<commit_message>
last update before submission
</commit_message>
<xml_diff>
--- a/flowchart.pptx
+++ b/flowchart.pptx
@@ -259,7 +259,7 @@
           <a:p>
             <a:fld id="{2A846C9A-3B73-4072-A1B3-7C15C8E1070C}" type="datetimeFigureOut">
               <a:rPr lang="en-US" smtClean="0"/>
-              <a:t>2/1/2026</a:t>
+              <a:t>2/5/2026</a:t>
             </a:fld>
             <a:endParaRPr lang="en-US"/>
           </a:p>
@@ -457,7 +457,7 @@
           <a:p>
             <a:fld id="{2A846C9A-3B73-4072-A1B3-7C15C8E1070C}" type="datetimeFigureOut">
               <a:rPr lang="en-US" smtClean="0"/>
-              <a:t>2/1/2026</a:t>
+              <a:t>2/5/2026</a:t>
             </a:fld>
             <a:endParaRPr lang="en-US"/>
           </a:p>
@@ -665,7 +665,7 @@
           <a:p>
             <a:fld id="{2A846C9A-3B73-4072-A1B3-7C15C8E1070C}" type="datetimeFigureOut">
               <a:rPr lang="en-US" smtClean="0"/>
-              <a:t>2/1/2026</a:t>
+              <a:t>2/5/2026</a:t>
             </a:fld>
             <a:endParaRPr lang="en-US"/>
           </a:p>
@@ -863,7 +863,7 @@
           <a:p>
             <a:fld id="{2A846C9A-3B73-4072-A1B3-7C15C8E1070C}" type="datetimeFigureOut">
               <a:rPr lang="en-US" smtClean="0"/>
-              <a:t>2/1/2026</a:t>
+              <a:t>2/5/2026</a:t>
             </a:fld>
             <a:endParaRPr lang="en-US"/>
           </a:p>
@@ -1138,7 +1138,7 @@
           <a:p>
             <a:fld id="{2A846C9A-3B73-4072-A1B3-7C15C8E1070C}" type="datetimeFigureOut">
               <a:rPr lang="en-US" smtClean="0"/>
-              <a:t>2/1/2026</a:t>
+              <a:t>2/5/2026</a:t>
             </a:fld>
             <a:endParaRPr lang="en-US"/>
           </a:p>
@@ -1403,7 +1403,7 @@
           <a:p>
             <a:fld id="{2A846C9A-3B73-4072-A1B3-7C15C8E1070C}" type="datetimeFigureOut">
               <a:rPr lang="en-US" smtClean="0"/>
-              <a:t>2/1/2026</a:t>
+              <a:t>2/5/2026</a:t>
             </a:fld>
             <a:endParaRPr lang="en-US"/>
           </a:p>
@@ -1815,7 +1815,7 @@
           <a:p>
             <a:fld id="{2A846C9A-3B73-4072-A1B3-7C15C8E1070C}" type="datetimeFigureOut">
               <a:rPr lang="en-US" smtClean="0"/>
-              <a:t>2/1/2026</a:t>
+              <a:t>2/5/2026</a:t>
             </a:fld>
             <a:endParaRPr lang="en-US"/>
           </a:p>
@@ -1956,7 +1956,7 @@
           <a:p>
             <a:fld id="{2A846C9A-3B73-4072-A1B3-7C15C8E1070C}" type="datetimeFigureOut">
               <a:rPr lang="en-US" smtClean="0"/>
-              <a:t>2/1/2026</a:t>
+              <a:t>2/5/2026</a:t>
             </a:fld>
             <a:endParaRPr lang="en-US"/>
           </a:p>
@@ -2069,7 +2069,7 @@
           <a:p>
             <a:fld id="{2A846C9A-3B73-4072-A1B3-7C15C8E1070C}" type="datetimeFigureOut">
               <a:rPr lang="en-US" smtClean="0"/>
-              <a:t>2/1/2026</a:t>
+              <a:t>2/5/2026</a:t>
             </a:fld>
             <a:endParaRPr lang="en-US"/>
           </a:p>
@@ -2380,7 +2380,7 @@
           <a:p>
             <a:fld id="{2A846C9A-3B73-4072-A1B3-7C15C8E1070C}" type="datetimeFigureOut">
               <a:rPr lang="en-US" smtClean="0"/>
-              <a:t>2/1/2026</a:t>
+              <a:t>2/5/2026</a:t>
             </a:fld>
             <a:endParaRPr lang="en-US"/>
           </a:p>
@@ -2668,7 +2668,7 @@
           <a:p>
             <a:fld id="{2A846C9A-3B73-4072-A1B3-7C15C8E1070C}" type="datetimeFigureOut">
               <a:rPr lang="en-US" smtClean="0"/>
-              <a:t>2/1/2026</a:t>
+              <a:t>2/5/2026</a:t>
             </a:fld>
             <a:endParaRPr lang="en-US"/>
           </a:p>
@@ -2909,7 +2909,7 @@
           <a:p>
             <a:fld id="{2A846C9A-3B73-4072-A1B3-7C15C8E1070C}" type="datetimeFigureOut">
               <a:rPr lang="en-US" smtClean="0"/>
-              <a:t>2/1/2026</a:t>
+              <a:t>2/5/2026</a:t>
             </a:fld>
             <a:endParaRPr lang="en-US"/>
           </a:p>
@@ -3340,8 +3340,8 @@
         </p:nvSpPr>
         <p:spPr>
           <a:xfrm>
-            <a:off x="2562859" y="2505455"/>
-            <a:ext cx="2444545" cy="2551173"/>
+            <a:off x="2597953" y="2376555"/>
+            <a:ext cx="2444545" cy="2680073"/>
           </a:xfrm>
           <a:prstGeom prst="roundRect">
             <a:avLst/>
@@ -3365,6 +3365,7 @@
           <a:bodyPr rtlCol="0" anchor="ctr"/>
           <a:lstStyle/>
           <a:p>
+            <a:pPr algn="ctr"/>
             <a:r>
               <a:rPr lang="en-US" sz="1400" b="1" dirty="0">
                 <a:latin typeface="Times New Roman" panose="02020603050405020304" pitchFamily="18" charset="0"/>
@@ -3468,6 +3469,7 @@
           <a:bodyPr rtlCol="0" anchor="ctr"/>
           <a:lstStyle/>
           <a:p>
+            <a:pPr algn="ctr"/>
             <a:r>
               <a:rPr lang="en-US" sz="1400" b="1" dirty="0">
                 <a:latin typeface="Times New Roman" panose="02020603050405020304" pitchFamily="18" charset="0"/>
@@ -3482,7 +3484,7 @@
                 <a:latin typeface="Times New Roman" panose="02020603050405020304" pitchFamily="18" charset="0"/>
                 <a:cs typeface="Times New Roman" panose="02020603050405020304" pitchFamily="18" charset="0"/>
               </a:rPr>
-              <a:t>5D CycIF Volume     V (T, C, Z, Y, X)     Parameters: r, R, </a:t>
+              <a:t>5D CycIF Volume     V (t, c, z, y, x)     Parameters: r, </a:t>
             </a:r>
             <a:r>
               <a:rPr lang="el-GR" sz="1200" dirty="0">
@@ -3537,6 +3539,7 @@
           <a:bodyPr rtlCol="0" anchor="ctr"/>
           <a:lstStyle/>
           <a:p>
+            <a:pPr algn="ctr"/>
             <a:r>
               <a:rPr lang="en-US" sz="1400" b="1" dirty="0">
                 <a:latin typeface="Times New Roman" panose="02020603050405020304" pitchFamily="18" charset="0"/>
@@ -3595,6 +3598,7 @@
           <a:bodyPr rtlCol="0" anchor="ctr"/>
           <a:lstStyle/>
           <a:p>
+            <a:pPr algn="ctr"/>
             <a:r>
               <a:rPr lang="en-US" sz="1400" b="1" dirty="0">
                 <a:latin typeface="Times New Roman" panose="02020603050405020304" pitchFamily="18" charset="0"/>
@@ -3612,11 +3616,25 @@
               <a:t>Group biomarkers into category </a:t>
             </a:r>
             <a:r>
+              <a:rPr lang="en-US" sz="1400" dirty="0" err="1">
+                <a:latin typeface="Times New Roman" panose="02020603050405020304" pitchFamily="18" charset="0"/>
+                <a:cs typeface="Times New Roman" panose="02020603050405020304" pitchFamily="18" charset="0"/>
+              </a:rPr>
+              <a:t>c</a:t>
+            </a:r>
+            <a:r>
               <a:rPr lang="en-US" sz="1200" dirty="0" err="1">
                 <a:latin typeface="Times New Roman" panose="02020603050405020304" pitchFamily="18" charset="0"/>
                 <a:cs typeface="Times New Roman" panose="02020603050405020304" pitchFamily="18" charset="0"/>
               </a:rPr>
-              <a:t>C_k</a:t>
+              <a:t>_</a:t>
+            </a:r>
+            <a:r>
+              <a:rPr lang="en-US" sz="1050" dirty="0" err="1">
+                <a:latin typeface="Times New Roman" panose="02020603050405020304" pitchFamily="18" charset="0"/>
+                <a:cs typeface="Times New Roman" panose="02020603050405020304" pitchFamily="18" charset="0"/>
+              </a:rPr>
+              <a:t>k</a:t>
             </a:r>
             <a:endParaRPr lang="en-US" sz="1200" dirty="0">
               <a:latin typeface="Times New Roman" panose="02020603050405020304" pitchFamily="18" charset="0"/>
@@ -3639,7 +3657,7 @@
         </p:nvSpPr>
         <p:spPr>
           <a:xfrm>
-            <a:off x="3792104" y="1175078"/>
+            <a:off x="3831136" y="1175553"/>
             <a:ext cx="948117" cy="261610"/>
           </a:xfrm>
           <a:prstGeom prst="rect">
@@ -3706,6 +3724,7 @@
           <a:bodyPr rtlCol="0" anchor="ctr"/>
           <a:lstStyle/>
           <a:p>
+            <a:pPr algn="ctr"/>
             <a:r>
               <a:rPr lang="en-US" sz="1400" b="1" dirty="0">
                 <a:latin typeface="Times New Roman" panose="02020603050405020304" pitchFamily="18" charset="0"/>
@@ -3811,8 +3830,8 @@
         </p:nvSpPr>
         <p:spPr>
           <a:xfrm>
-            <a:off x="6173343" y="1429463"/>
-            <a:ext cx="1307488" cy="430887"/>
+            <a:off x="6221802" y="1439006"/>
+            <a:ext cx="1307488" cy="276999"/>
           </a:xfrm>
           <a:prstGeom prst="rect">
             <a:avLst/>
@@ -3826,34 +3845,67 @@
           <a:lstStyle/>
           <a:p>
             <a:r>
+              <a:rPr lang="en-US" sz="1200" b="1" dirty="0" err="1">
+                <a:latin typeface="Times New Roman" panose="02020603050405020304" pitchFamily="18" charset="0"/>
+                <a:cs typeface="Times New Roman" panose="02020603050405020304" pitchFamily="18" charset="0"/>
+              </a:rPr>
+              <a:t>f_</a:t>
+            </a:r>
+            <a:r>
+              <a:rPr lang="en-US" sz="1100" dirty="0" err="1">
+                <a:latin typeface="Times New Roman" panose="02020603050405020304" pitchFamily="18" charset="0"/>
+                <a:cs typeface="Times New Roman" panose="02020603050405020304" pitchFamily="18" charset="0"/>
+              </a:rPr>
+              <a:t>i</a:t>
+            </a:r>
+            <a:r>
               <a:rPr lang="en-US" sz="1100" dirty="0">
                 <a:latin typeface="Times New Roman" panose="02020603050405020304" pitchFamily="18" charset="0"/>
                 <a:cs typeface="Times New Roman" panose="02020603050405020304" pitchFamily="18" charset="0"/>
               </a:rPr>
-              <a:t>Fi​=[xi​,</a:t>
-            </a:r>
-            <a:r>
-              <a:rPr lang="en-US" sz="1100" dirty="0" err="1">
-                <a:latin typeface="Times New Roman" panose="02020603050405020304" pitchFamily="18" charset="0"/>
-                <a:cs typeface="Times New Roman" panose="02020603050405020304" pitchFamily="18" charset="0"/>
-              </a:rPr>
-              <a:t>Ii</a:t>
+              <a:t>​=[</a:t>
+            </a:r>
+            <a:r>
+              <a:rPr lang="en-US" sz="1200" b="1" dirty="0">
+                <a:latin typeface="Times New Roman" panose="02020603050405020304" pitchFamily="18" charset="0"/>
+                <a:cs typeface="Times New Roman" panose="02020603050405020304" pitchFamily="18" charset="0"/>
+              </a:rPr>
+              <a:t>x</a:t>
             </a:r>
             <a:r>
               <a:rPr lang="en-US" sz="1100" dirty="0">
                 <a:latin typeface="Times New Roman" panose="02020603050405020304" pitchFamily="18" charset="0"/>
                 <a:cs typeface="Times New Roman" panose="02020603050405020304" pitchFamily="18" charset="0"/>
               </a:rPr>
-              <a:t>​,ci​]</a:t>
-            </a:r>
-          </a:p>
-          <a:p>
+              <a:t>i​,</a:t>
+            </a:r>
+            <a:r>
+              <a:rPr lang="en-US" sz="1200" b="1" dirty="0">
+                <a:latin typeface="Times New Roman" panose="02020603050405020304" pitchFamily="18" charset="0"/>
+                <a:cs typeface="Times New Roman" panose="02020603050405020304" pitchFamily="18" charset="0"/>
+              </a:rPr>
+              <a:t>i</a:t>
+            </a:r>
             <a:r>
               <a:rPr lang="en-US" sz="1100" dirty="0">
                 <a:latin typeface="Times New Roman" panose="02020603050405020304" pitchFamily="18" charset="0"/>
                 <a:cs typeface="Times New Roman" panose="02020603050405020304" pitchFamily="18" charset="0"/>
               </a:rPr>
-              <a:t>Eᵢ = [xᵢ, wᵢ, ci] </a:t>
+              <a:t>i​,</a:t>
+            </a:r>
+            <a:r>
+              <a:rPr lang="en-US" sz="1200" b="1" dirty="0">
+                <a:latin typeface="Times New Roman" panose="02020603050405020304" pitchFamily="18" charset="0"/>
+                <a:cs typeface="Times New Roman" panose="02020603050405020304" pitchFamily="18" charset="0"/>
+              </a:rPr>
+              <a:t>c</a:t>
+            </a:r>
+            <a:r>
+              <a:rPr lang="en-US" sz="1100" dirty="0">
+                <a:latin typeface="Times New Roman" panose="02020603050405020304" pitchFamily="18" charset="0"/>
+                <a:cs typeface="Times New Roman" panose="02020603050405020304" pitchFamily="18" charset="0"/>
+              </a:rPr>
+              <a:t>i​]</a:t>
             </a:r>
           </a:p>
         </p:txBody>
@@ -3872,8 +3924,8 @@
         </p:nvSpPr>
         <p:spPr>
           <a:xfrm>
-            <a:off x="10344912" y="1015587"/>
-            <a:ext cx="1664208" cy="818940"/>
+            <a:off x="10479024" y="1015587"/>
+            <a:ext cx="1530096" cy="818940"/>
           </a:xfrm>
           <a:prstGeom prst="rect">
             <a:avLst/>
@@ -3897,6 +3949,7 @@
           <a:bodyPr rtlCol="0" anchor="ctr"/>
           <a:lstStyle/>
           <a:p>
+            <a:pPr algn="ctr"/>
             <a:r>
               <a:rPr lang="en-US" sz="1400" b="1" dirty="0">
                 <a:latin typeface="Times New Roman" panose="02020603050405020304" pitchFamily="18" charset="0"/>
@@ -3974,6 +4027,13 @@
           </a:p>
           <a:p>
             <a:r>
+              <a:rPr lang="en-US" sz="1100" dirty="0">
+                <a:latin typeface="Times New Roman" panose="02020603050405020304" pitchFamily="18" charset="0"/>
+                <a:cs typeface="Times New Roman" panose="02020603050405020304" pitchFamily="18" charset="0"/>
+              </a:rPr>
+              <a:t>      </a:t>
+            </a:r>
+            <a:r>
               <a:rPr lang="pl-PL" sz="1100" dirty="0">
                 <a:latin typeface="Times New Roman" panose="02020603050405020304" pitchFamily="18" charset="0"/>
                 <a:cs typeface="Times New Roman" panose="02020603050405020304" pitchFamily="18" charset="0"/>
@@ -4005,12 +4065,12 @@
         </p:nvCxnSpPr>
         <p:spPr>
           <a:xfrm rot="5400000">
-            <a:off x="5300566" y="-2895125"/>
-            <a:ext cx="1146798" cy="10606102"/>
+            <a:off x="5334094" y="-2928653"/>
+            <a:ext cx="1146798" cy="10673158"/>
           </a:xfrm>
           <a:prstGeom prst="bentConnector3">
             <a:avLst>
-              <a:gd name="adj1" fmla="val 43621"/>
+              <a:gd name="adj1" fmla="val 41229"/>
             </a:avLst>
           </a:prstGeom>
           <a:ln>
@@ -4061,46 +4121,11 @@
           <a:lstStyle/>
           <a:p>
             <a:r>
-              <a:rPr lang="en-US" sz="1200" dirty="0" err="1">
-                <a:latin typeface="Times New Roman" panose="02020603050405020304" pitchFamily="18" charset="0"/>
-                <a:cs typeface="Times New Roman" panose="02020603050405020304" pitchFamily="18" charset="0"/>
-              </a:rPr>
-              <a:t>Z_i</a:t>
-            </a:r>
-            <a:r>
               <a:rPr lang="en-US" sz="1200" dirty="0">
                 <a:latin typeface="Times New Roman" panose="02020603050405020304" pitchFamily="18" charset="0"/>
                 <a:cs typeface="Times New Roman" panose="02020603050405020304" pitchFamily="18" charset="0"/>
               </a:rPr>
-              <a:t> = GAT(</a:t>
-            </a:r>
-            <a:r>
-              <a:rPr lang="en-US" sz="1200" dirty="0" err="1">
-                <a:latin typeface="Times New Roman" panose="02020603050405020304" pitchFamily="18" charset="0"/>
-                <a:cs typeface="Times New Roman" panose="02020603050405020304" pitchFamily="18" charset="0"/>
-              </a:rPr>
-              <a:t>F_i</a:t>
-            </a:r>
-            <a:r>
-              <a:rPr lang="en-US" sz="1200" dirty="0">
-                <a:latin typeface="Times New Roman" panose="02020603050405020304" pitchFamily="18" charset="0"/>
-                <a:cs typeface="Times New Roman" panose="02020603050405020304" pitchFamily="18" charset="0"/>
-              </a:rPr>
-              <a:t>, </a:t>
-            </a:r>
-            <a:r>
-              <a:rPr lang="en-US" sz="1200" dirty="0" err="1">
-                <a:latin typeface="Times New Roman" panose="02020603050405020304" pitchFamily="18" charset="0"/>
-                <a:cs typeface="Times New Roman" panose="02020603050405020304" pitchFamily="18" charset="0"/>
-              </a:rPr>
-              <a:t>E_i</a:t>
-            </a:r>
-            <a:r>
-              <a:rPr lang="en-US" sz="1200" dirty="0">
-                <a:latin typeface="Times New Roman" panose="02020603050405020304" pitchFamily="18" charset="0"/>
-                <a:cs typeface="Times New Roman" panose="02020603050405020304" pitchFamily="18" charset="0"/>
-              </a:rPr>
-              <a:t>) </a:t>
+              <a:t>Z = GAT(N, E) </a:t>
             </a:r>
           </a:p>
         </p:txBody>
@@ -4119,7 +4144,7 @@
         </p:nvSpPr>
         <p:spPr>
           <a:xfrm>
-            <a:off x="3033949" y="2805376"/>
+            <a:off x="3069043" y="2805376"/>
             <a:ext cx="1900007" cy="546906"/>
           </a:xfrm>
           <a:prstGeom prst="rect">
@@ -4144,6 +4169,7 @@
           <a:bodyPr rtlCol="0" anchor="ctr"/>
           <a:lstStyle/>
           <a:p>
+            <a:pPr algn="ctr"/>
             <a:r>
               <a:rPr lang="en-US" sz="1400" b="1" dirty="0">
                 <a:latin typeface="Times New Roman" panose="02020603050405020304" pitchFamily="18" charset="0"/>
@@ -4194,7 +4220,7 @@
         </p:nvSpPr>
         <p:spPr>
           <a:xfrm>
-            <a:off x="2965945" y="3611919"/>
+            <a:off x="3001039" y="3611919"/>
             <a:ext cx="1971190" cy="546906"/>
           </a:xfrm>
           <a:prstGeom prst="rect">
@@ -4219,6 +4245,7 @@
           <a:bodyPr rtlCol="0" anchor="ctr"/>
           <a:lstStyle/>
           <a:p>
+            <a:pPr algn="ctr"/>
             <a:r>
               <a:rPr lang="en-US" sz="1400" b="1" dirty="0">
                 <a:latin typeface="Times New Roman" panose="02020603050405020304" pitchFamily="18" charset="0"/>
@@ -4289,7 +4316,7 @@
         </p:nvSpPr>
         <p:spPr>
           <a:xfrm>
-            <a:off x="3033948" y="4418462"/>
+            <a:off x="3069042" y="4418462"/>
             <a:ext cx="1900005" cy="439357"/>
           </a:xfrm>
           <a:prstGeom prst="rect">
@@ -4314,6 +4341,7 @@
           <a:bodyPr rtlCol="0" anchor="ctr"/>
           <a:lstStyle/>
           <a:p>
+            <a:pPr algn="ctr"/>
             <a:r>
               <a:rPr lang="en-US" sz="1400" b="1" dirty="0">
                 <a:latin typeface="Times New Roman" panose="02020603050405020304" pitchFamily="18" charset="0"/>
@@ -4355,7 +4383,7 @@
         </p:nvCxnSpPr>
         <p:spPr>
           <a:xfrm rot="10800000" flipH="1">
-            <a:off x="3033947" y="3078829"/>
+            <a:off x="3069041" y="3078829"/>
             <a:ext cx="1" cy="1559312"/>
           </a:xfrm>
           <a:prstGeom prst="bentConnector3">
@@ -4396,7 +4424,7 @@
         </p:nvSpPr>
         <p:spPr>
           <a:xfrm rot="16200000">
-            <a:off x="1679703" y="3717002"/>
+            <a:off x="1714797" y="3717002"/>
             <a:ext cx="1973856" cy="307777"/>
           </a:xfrm>
           <a:prstGeom prst="rect">
@@ -4437,7 +4465,7 @@
         </p:nvCxnSpPr>
         <p:spPr>
           <a:xfrm>
-            <a:off x="3949699" y="3386389"/>
+            <a:off x="3984793" y="3386389"/>
             <a:ext cx="1841" cy="225530"/>
           </a:xfrm>
           <a:prstGeom prst="straightConnector1">
@@ -4478,7 +4506,7 @@
         </p:nvCxnSpPr>
         <p:spPr>
           <a:xfrm>
-            <a:off x="3954445" y="4158825"/>
+            <a:off x="3989539" y="4158825"/>
             <a:ext cx="0" cy="259637"/>
           </a:xfrm>
           <a:prstGeom prst="straightConnector1">
@@ -4514,13 +4542,12 @@
           </p:cNvPr>
           <p:cNvCxnSpPr>
             <a:cxnSpLocks/>
-            <a:stCxn id="62" idx="3"/>
           </p:cNvCxnSpPr>
           <p:nvPr/>
         </p:nvCxnSpPr>
         <p:spPr>
           <a:xfrm>
-            <a:off x="1086278" y="3429000"/>
+            <a:off x="1104566" y="3429000"/>
             <a:ext cx="1476581" cy="0"/>
           </a:xfrm>
           <a:prstGeom prst="straightConnector1">
@@ -4578,14 +4605,42 @@
                 <a:latin typeface="Times New Roman" panose="02020603050405020304" pitchFamily="18" charset="0"/>
                 <a:cs typeface="Times New Roman" panose="02020603050405020304" pitchFamily="18" charset="0"/>
               </a:rPr>
-              <a:t>S</a:t>
+              <a:t>s</a:t>
             </a:r>
             <a:r>
               <a:rPr lang="pl-PL" sz="1100" dirty="0">
                 <a:latin typeface="Times New Roman" panose="02020603050405020304" pitchFamily="18" charset="0"/>
                 <a:cs typeface="Times New Roman" panose="02020603050405020304" pitchFamily="18" charset="0"/>
               </a:rPr>
-              <a:t>_i(k) = σ(w_kᵀ Z_i)</a:t>
+              <a:t>_i(k) = σ(</a:t>
+            </a:r>
+            <a:r>
+              <a:rPr lang="pl-PL" sz="1100" b="1" dirty="0">
+                <a:latin typeface="Times New Roman" panose="02020603050405020304" pitchFamily="18" charset="0"/>
+                <a:cs typeface="Times New Roman" panose="02020603050405020304" pitchFamily="18" charset="0"/>
+              </a:rPr>
+              <a:t>w_</a:t>
+            </a:r>
+            <a:r>
+              <a:rPr lang="pl-PL" sz="1100" dirty="0">
+                <a:latin typeface="Times New Roman" panose="02020603050405020304" pitchFamily="18" charset="0"/>
+                <a:cs typeface="Times New Roman" panose="02020603050405020304" pitchFamily="18" charset="0"/>
+              </a:rPr>
+              <a:t>kᵀ </a:t>
+            </a:r>
+            <a:r>
+              <a:rPr lang="en-US" sz="1100" b="1" dirty="0">
+                <a:latin typeface="Times New Roman" panose="02020603050405020304" pitchFamily="18" charset="0"/>
+                <a:cs typeface="Times New Roman" panose="02020603050405020304" pitchFamily="18" charset="0"/>
+              </a:rPr>
+              <a:t>z</a:t>
+            </a:r>
+            <a:r>
+              <a:rPr lang="pl-PL" sz="1100" dirty="0">
+                <a:latin typeface="Times New Roman" panose="02020603050405020304" pitchFamily="18" charset="0"/>
+                <a:cs typeface="Times New Roman" panose="02020603050405020304" pitchFamily="18" charset="0"/>
+              </a:rPr>
+              <a:t>_i)</a:t>
             </a:r>
             <a:endParaRPr lang="en-US" sz="1100" dirty="0">
               <a:latin typeface="Times New Roman" panose="02020603050405020304" pitchFamily="18" charset="0"/>
@@ -4608,8 +4663,8 @@
         </p:nvSpPr>
         <p:spPr>
           <a:xfrm>
-            <a:off x="5426413" y="2758377"/>
-            <a:ext cx="1167046" cy="1618628"/>
+            <a:off x="5427855" y="2924910"/>
+            <a:ext cx="1176708" cy="1171696"/>
           </a:xfrm>
           <a:prstGeom prst="rect">
             <a:avLst/>
@@ -4698,8 +4753,8 @@
         </p:nvSpPr>
         <p:spPr>
           <a:xfrm>
-            <a:off x="6560406" y="3508528"/>
-            <a:ext cx="1162448" cy="261610"/>
+            <a:off x="6587314" y="3144179"/>
+            <a:ext cx="1162448" cy="307777"/>
           </a:xfrm>
           <a:prstGeom prst="rect">
             <a:avLst/>
@@ -4713,26 +4768,37 @@
           <a:lstStyle/>
           <a:p>
             <a:r>
-              <a:rPr lang="en-US" sz="1100" dirty="0">
-                <a:latin typeface="Times New Roman" panose="02020603050405020304" pitchFamily="18" charset="0"/>
-                <a:cs typeface="Times New Roman" panose="02020603050405020304" pitchFamily="18" charset="0"/>
-              </a:rPr>
-              <a:t>S</a:t>
-            </a:r>
-            <a:r>
-              <a:rPr lang="pl-PL" sz="1100" dirty="0">
-                <a:latin typeface="Times New Roman" panose="02020603050405020304" pitchFamily="18" charset="0"/>
-                <a:cs typeface="Times New Roman" panose="02020603050405020304" pitchFamily="18" charset="0"/>
-              </a:rPr>
-              <a:t>_i</a:t>
-            </a:r>
-            <a:r>
-              <a:rPr lang="en-US" sz="1100" dirty="0">
-                <a:latin typeface="Times New Roman" panose="02020603050405020304" pitchFamily="18" charset="0"/>
-                <a:cs typeface="Times New Roman" panose="02020603050405020304" pitchFamily="18" charset="0"/>
-              </a:rPr>
-              <a:t>={s_1,..,s_m}</a:t>
-            </a:r>
+              <a:rPr lang="en-US" sz="1400" b="1" dirty="0">
+                <a:latin typeface="Times New Roman" panose="02020603050405020304" pitchFamily="18" charset="0"/>
+                <a:cs typeface="Times New Roman" panose="02020603050405020304" pitchFamily="18" charset="0"/>
+              </a:rPr>
+              <a:t>s</a:t>
+            </a:r>
+            <a:r>
+              <a:rPr lang="pl-PL" sz="1400" dirty="0">
+                <a:latin typeface="Times New Roman" panose="02020603050405020304" pitchFamily="18" charset="0"/>
+                <a:cs typeface="Times New Roman" panose="02020603050405020304" pitchFamily="18" charset="0"/>
+              </a:rPr>
+              <a:t>_</a:t>
+            </a:r>
+            <a:r>
+              <a:rPr lang="en-US" sz="1400" dirty="0" err="1">
+                <a:latin typeface="Times New Roman" panose="02020603050405020304" pitchFamily="18" charset="0"/>
+                <a:cs typeface="Times New Roman" panose="02020603050405020304" pitchFamily="18" charset="0"/>
+              </a:rPr>
+              <a:t>i</a:t>
+            </a:r>
+            <a:r>
+              <a:rPr lang="en-US" sz="1400" dirty="0">
+                <a:latin typeface="Times New Roman" panose="02020603050405020304" pitchFamily="18" charset="0"/>
+                <a:cs typeface="Times New Roman" panose="02020603050405020304" pitchFamily="18" charset="0"/>
+              </a:rPr>
+              <a:t>⁽ᵏ⁾</a:t>
+            </a:r>
+            <a:endParaRPr lang="en-US" sz="1200" dirty="0">
+              <a:latin typeface="Times New Roman" panose="02020603050405020304" pitchFamily="18" charset="0"/>
+              <a:cs typeface="Times New Roman" panose="02020603050405020304" pitchFamily="18" charset="0"/>
+            </a:endParaRPr>
           </a:p>
         </p:txBody>
       </p:sp>
@@ -4751,7 +4817,7 @@
         <p:spPr>
           <a:xfrm>
             <a:off x="5000515" y="3125177"/>
-            <a:ext cx="607056" cy="600164"/>
+            <a:ext cx="607056" cy="646331"/>
           </a:xfrm>
           <a:prstGeom prst="rect">
             <a:avLst/>
@@ -4765,39 +4831,46 @@
           <a:lstStyle/>
           <a:p>
             <a:r>
-              <a:rPr lang="en-US" sz="1100" dirty="0" err="1">
-                <a:latin typeface="Times New Roman" panose="02020603050405020304" pitchFamily="18" charset="0"/>
-                <a:cs typeface="Times New Roman" panose="02020603050405020304" pitchFamily="18" charset="0"/>
-              </a:rPr>
-              <a:t>W_k</a:t>
-            </a:r>
-            <a:endParaRPr lang="en-US" sz="1100" dirty="0">
+              <a:rPr lang="en-US" sz="1200" b="1" dirty="0" err="1">
+                <a:latin typeface="Times New Roman" panose="02020603050405020304" pitchFamily="18" charset="0"/>
+                <a:cs typeface="Times New Roman" panose="02020603050405020304" pitchFamily="18" charset="0"/>
+              </a:rPr>
+              <a:t>w_k</a:t>
+            </a:r>
+            <a:endParaRPr lang="en-US" sz="1200" b="1" dirty="0">
               <a:latin typeface="Times New Roman" panose="02020603050405020304" pitchFamily="18" charset="0"/>
               <a:cs typeface="Times New Roman" panose="02020603050405020304" pitchFamily="18" charset="0"/>
             </a:endParaRPr>
           </a:p>
           <a:p>
             <a:r>
-              <a:rPr lang="en-US" sz="1100" dirty="0">
+              <a:rPr lang="en-US" sz="1200" dirty="0">
                 <a:latin typeface="Times New Roman" panose="02020603050405020304" pitchFamily="18" charset="0"/>
                 <a:cs typeface="Times New Roman" panose="02020603050405020304" pitchFamily="18" charset="0"/>
               </a:rPr>
               <a:t> </a:t>
             </a:r>
             <a:br>
-              <a:rPr lang="en-US" sz="1100" dirty="0">
+              <a:rPr lang="en-US" sz="1200" dirty="0">
                 <a:latin typeface="Times New Roman" panose="02020603050405020304" pitchFamily="18" charset="0"/>
                 <a:cs typeface="Times New Roman" panose="02020603050405020304" pitchFamily="18" charset="0"/>
               </a:rPr>
             </a:br>
             <a:r>
-              <a:rPr lang="pl-PL" sz="1100" dirty="0">
-                <a:latin typeface="Times New Roman" panose="02020603050405020304" pitchFamily="18" charset="0"/>
-                <a:cs typeface="Times New Roman" panose="02020603050405020304" pitchFamily="18" charset="0"/>
-              </a:rPr>
-              <a:t>Z_i</a:t>
-            </a:r>
-            <a:endParaRPr lang="en-US" sz="1100" dirty="0">
+              <a:rPr lang="en-US" sz="1200" b="1" dirty="0">
+                <a:latin typeface="Times New Roman" panose="02020603050405020304" pitchFamily="18" charset="0"/>
+                <a:cs typeface="Times New Roman" panose="02020603050405020304" pitchFamily="18" charset="0"/>
+              </a:rPr>
+              <a:t>z</a:t>
+            </a:r>
+            <a:r>
+              <a:rPr lang="pl-PL" sz="1200" b="1" dirty="0">
+                <a:latin typeface="Times New Roman" panose="02020603050405020304" pitchFamily="18" charset="0"/>
+                <a:cs typeface="Times New Roman" panose="02020603050405020304" pitchFamily="18" charset="0"/>
+              </a:rPr>
+              <a:t>_i</a:t>
+            </a:r>
+            <a:endParaRPr lang="en-US" sz="1200" b="1" dirty="0">
               <a:latin typeface="Times New Roman" panose="02020603050405020304" pitchFamily="18" charset="0"/>
               <a:cs typeface="Times New Roman" panose="02020603050405020304" pitchFamily="18" charset="0"/>
             </a:endParaRPr>
@@ -4818,8 +4891,8 @@
         </p:nvSpPr>
         <p:spPr>
           <a:xfrm>
-            <a:off x="7670894" y="2460229"/>
-            <a:ext cx="2356060" cy="2680073"/>
+            <a:off x="7670894" y="2376555"/>
+            <a:ext cx="2353534" cy="2763747"/>
           </a:xfrm>
           <a:prstGeom prst="roundRect">
             <a:avLst/>
@@ -4843,6 +4916,7 @@
           <a:bodyPr rtlCol="0" anchor="ctr"/>
           <a:lstStyle/>
           <a:p>
+            <a:pPr algn="ctr"/>
             <a:r>
               <a:rPr lang="en-US" sz="1400" b="1" dirty="0">
                 <a:latin typeface="Times New Roman" panose="02020603050405020304" pitchFamily="18" charset="0"/>
@@ -4946,6 +5020,7 @@
           <a:bodyPr rtlCol="0" anchor="ctr"/>
           <a:lstStyle/>
           <a:p>
+            <a:pPr algn="ctr"/>
             <a:r>
               <a:rPr lang="en-US" sz="1400" b="1" dirty="0">
                 <a:latin typeface="Times New Roman" panose="02020603050405020304" pitchFamily="18" charset="0"/>
@@ -4956,8 +5031,12 @@
           </a:p>
           <a:p>
             <a:r>
+              <a:rPr lang="en-US" sz="1400" b="1" dirty="0" err="1"/>
+              <a:t>i</a:t>
+            </a:r>
+            <a:r>
               <a:rPr lang="en-US" sz="1200" dirty="0"/>
-              <a:t>Iᵢⱼ⁽ᵏ⁾ = sᵢ⁽ᵏ⁾ · sⱼ⁽ᵏ⁾ · Īᵢ⁽ᵏ⁾ · Īⱼ⁽ᵏ⁾ · wij</a:t>
+              <a:t>ᵢⱼ⁽ᵏ⁾ = sᵢ⁽ᵏ⁾ · sⱼ⁽ᵏ⁾ · Īᵢ⁽ᵏ⁾ · Īⱼ⁽ᵏ⁾ · wij</a:t>
             </a:r>
             <a:endParaRPr lang="en-US" sz="900" dirty="0">
               <a:latin typeface="Times New Roman" panose="02020603050405020304" pitchFamily="18" charset="0"/>
@@ -5005,6 +5084,7 @@
           <a:bodyPr rtlCol="0" anchor="ctr"/>
           <a:lstStyle/>
           <a:p>
+            <a:pPr algn="ctr"/>
             <a:r>
               <a:rPr lang="en-US" sz="1400" b="1" dirty="0">
                 <a:latin typeface="Times New Roman" panose="02020603050405020304" pitchFamily="18" charset="0"/>
@@ -5024,7 +5104,15 @@
             </a:r>
             <a:r>
               <a:rPr lang="en-US" sz="1200" dirty="0"/>
-              <a:t>) = max { Iᵢⱼ⁽ᵏ⁾ | j ∈ Nᵣ(</a:t>
+              <a:t>) = max {</a:t>
+            </a:r>
+            <a:r>
+              <a:rPr lang="en-US" sz="1400" b="1" dirty="0" err="1"/>
+              <a:t>i</a:t>
+            </a:r>
+            <a:r>
+              <a:rPr lang="en-US" sz="1200" dirty="0"/>
+              <a:t>ᵢⱼ⁽ᵏ⁾ | j ∈ Nᵣ(</a:t>
             </a:r>
             <a:r>
               <a:rPr lang="en-US" sz="1200" dirty="0" err="1"/>
@@ -5088,6 +5176,7 @@
           <a:bodyPr rtlCol="0" anchor="ctr"/>
           <a:lstStyle/>
           <a:p>
+            <a:pPr algn="ctr"/>
             <a:r>
               <a:rPr lang="en-US" sz="1400" b="1" dirty="0">
                 <a:latin typeface="Times New Roman" panose="02020603050405020304" pitchFamily="18" charset="0"/>
@@ -5218,7 +5307,7 @@
         </p:nvCxnSpPr>
         <p:spPr>
           <a:xfrm>
-            <a:off x="5007404" y="3435250"/>
+            <a:off x="5025692" y="3435250"/>
             <a:ext cx="419009" cy="2902"/>
           </a:xfrm>
           <a:prstGeom prst="straightConnector1">
@@ -5257,8 +5346,8 @@
         </p:nvSpPr>
         <p:spPr>
           <a:xfrm>
-            <a:off x="10734513" y="2845208"/>
-            <a:ext cx="1401937" cy="1180084"/>
+            <a:off x="10838484" y="2845208"/>
+            <a:ext cx="1261390" cy="1180084"/>
           </a:xfrm>
           <a:prstGeom prst="rect">
             <a:avLst/>
@@ -5282,6 +5371,7 @@
           <a:bodyPr rtlCol="0" anchor="ctr"/>
           <a:lstStyle/>
           <a:p>
+            <a:pPr algn="ctr"/>
             <a:r>
               <a:rPr lang="en-US" sz="1400" b="1" dirty="0">
                 <a:latin typeface="Times New Roman" panose="02020603050405020304" pitchFamily="18" charset="0"/>
@@ -5302,7 +5392,7 @@
                 <a:latin typeface="Times New Roman" panose="02020603050405020304" pitchFamily="18" charset="0"/>
                 <a:cs typeface="Times New Roman" panose="02020603050405020304" pitchFamily="18" charset="0"/>
               </a:rPr>
-              <a:t>-GAT model</a:t>
+              <a:t>- GAT model</a:t>
             </a:r>
             <a:br>
               <a:rPr lang="en-US" sz="1200" dirty="0">
@@ -5315,7 +5405,7 @@
                 <a:latin typeface="Times New Roman" panose="02020603050405020304" pitchFamily="18" charset="0"/>
                 <a:cs typeface="Times New Roman" panose="02020603050405020304" pitchFamily="18" charset="0"/>
               </a:rPr>
-              <a:t>-Saliency map </a:t>
+              <a:t>- Saliency map </a:t>
             </a:r>
           </a:p>
           <a:p>
@@ -5324,7 +5414,7 @@
                 <a:latin typeface="Times New Roman" panose="02020603050405020304" pitchFamily="18" charset="0"/>
                 <a:cs typeface="Times New Roman" panose="02020603050405020304" pitchFamily="18" charset="0"/>
               </a:rPr>
-              <a:t>-ROI masks</a:t>
+              <a:t>- ROI masks</a:t>
             </a:r>
           </a:p>
         </p:txBody>
@@ -5345,8 +5435,8 @@
         </p:nvCxnSpPr>
         <p:spPr>
           <a:xfrm>
-            <a:off x="10026954" y="3462664"/>
-            <a:ext cx="707559" cy="0"/>
+            <a:off x="10024428" y="3465755"/>
+            <a:ext cx="819129" cy="0"/>
           </a:xfrm>
           <a:prstGeom prst="straightConnector1">
             <a:avLst/>
@@ -5611,7 +5701,7 @@
         <p:spPr>
           <a:xfrm>
             <a:off x="9561928" y="1421332"/>
-            <a:ext cx="782984" cy="3725"/>
+            <a:ext cx="917096" cy="3725"/>
           </a:xfrm>
           <a:prstGeom prst="straightConnector1">
             <a:avLst/>
@@ -5668,7 +5758,7 @@
                 <a:latin typeface="Times New Roman" panose="02020603050405020304" pitchFamily="18" charset="0"/>
                 <a:cs typeface="Times New Roman" panose="02020603050405020304" pitchFamily="18" charset="0"/>
               </a:rPr>
-              <a:t>G=(V,E)</a:t>
+              <a:t>Nodes</a:t>
             </a:r>
           </a:p>
         </p:txBody>
@@ -5702,35 +5792,35 @@
           <a:lstStyle/>
           <a:p>
             <a:r>
-              <a:rPr lang="en-US" sz="1000" dirty="0">
-                <a:latin typeface="Times New Roman" panose="02020603050405020304" pitchFamily="18" charset="0"/>
-                <a:cs typeface="Times New Roman" panose="02020603050405020304" pitchFamily="18" charset="0"/>
-              </a:rPr>
-              <a:t>F</a:t>
-            </a:r>
-            <a:r>
-              <a:rPr lang="pl-PL" sz="1000" dirty="0">
+              <a:rPr lang="en-US" sz="1050" b="1" dirty="0">
+                <a:latin typeface="Times New Roman" panose="02020603050405020304" pitchFamily="18" charset="0"/>
+                <a:cs typeface="Times New Roman" panose="02020603050405020304" pitchFamily="18" charset="0"/>
+              </a:rPr>
+              <a:t>f</a:t>
+            </a:r>
+            <a:r>
+              <a:rPr lang="pl-PL" sz="1050" dirty="0">
                 <a:latin typeface="Times New Roman" panose="02020603050405020304" pitchFamily="18" charset="0"/>
                 <a:cs typeface="Times New Roman" panose="02020603050405020304" pitchFamily="18" charset="0"/>
               </a:rPr>
               <a:t>_i(k) = </a:t>
             </a:r>
             <a:r>
-              <a:rPr lang="en-US" sz="1000" dirty="0">
+              <a:rPr lang="en-US" sz="1050" dirty="0">
                 <a:latin typeface="Times New Roman" panose="02020603050405020304" pitchFamily="18" charset="0"/>
                 <a:cs typeface="Times New Roman" panose="02020603050405020304" pitchFamily="18" charset="0"/>
               </a:rPr>
               <a:t>{f_1(k),…,</a:t>
             </a:r>
             <a:r>
-              <a:rPr lang="en-US" sz="1000" dirty="0" err="1">
+              <a:rPr lang="en-US" sz="1050" dirty="0" err="1">
                 <a:latin typeface="Times New Roman" panose="02020603050405020304" pitchFamily="18" charset="0"/>
                 <a:cs typeface="Times New Roman" panose="02020603050405020304" pitchFamily="18" charset="0"/>
               </a:rPr>
               <a:t>f_m</a:t>
             </a:r>
             <a:r>
-              <a:rPr lang="en-US" sz="1000" dirty="0">
+              <a:rPr lang="en-US" sz="1050" dirty="0">
                 <a:latin typeface="Times New Roman" panose="02020603050405020304" pitchFamily="18" charset="0"/>
                 <a:cs typeface="Times New Roman" panose="02020603050405020304" pitchFamily="18" charset="0"/>
               </a:rPr>
@@ -5796,7 +5886,7 @@
         </p:nvSpPr>
         <p:spPr>
           <a:xfrm>
-            <a:off x="10024428" y="3161388"/>
+            <a:off x="10024428" y="2953583"/>
             <a:ext cx="663843" cy="261610"/>
           </a:xfrm>
           <a:prstGeom prst="rect">
@@ -5835,7 +5925,7 @@
         <p:spPr>
           <a:xfrm>
             <a:off x="9953420" y="3502331"/>
-            <a:ext cx="890137" cy="261610"/>
+            <a:ext cx="969004" cy="261610"/>
           </a:xfrm>
           <a:prstGeom prst="rect">
             <a:avLst/>
@@ -5853,7 +5943,208 @@
                 <a:latin typeface="Times New Roman" panose="02020603050405020304" pitchFamily="18" charset="0"/>
                 <a:cs typeface="Times New Roman" panose="02020603050405020304" pitchFamily="18" charset="0"/>
               </a:rPr>
-              <a:t>Coordinates</a:t>
+              <a:t> Coordinates</a:t>
+            </a:r>
+          </a:p>
+        </p:txBody>
+      </p:sp>
+      <p:sp>
+        <p:nvSpPr>
+          <p:cNvPr id="5" name="TextBox 4">
+            <a:extLst>
+              <a:ext uri="{FF2B5EF4-FFF2-40B4-BE49-F238E27FC236}">
+                <a16:creationId xmlns:a16="http://schemas.microsoft.com/office/drawing/2014/main" id="{5E1A420E-AF74-BA84-ADD1-C475680263BB}"/>
+              </a:ext>
+            </a:extLst>
+          </p:cNvPr>
+          <p:cNvSpPr txBox="1"/>
+          <p:nvPr/>
+        </p:nvSpPr>
+        <p:spPr>
+          <a:xfrm>
+            <a:off x="9550322" y="1461508"/>
+            <a:ext cx="928702" cy="261610"/>
+          </a:xfrm>
+          <a:prstGeom prst="rect">
+            <a:avLst/>
+          </a:prstGeom>
+          <a:noFill/>
+        </p:spPr>
+        <p:txBody>
+          <a:bodyPr wrap="square">
+            <a:spAutoFit/>
+          </a:bodyPr>
+          <a:lstStyle/>
+          <a:p>
+            <a:r>
+              <a:rPr lang="en-US" sz="1100" dirty="0">
+                <a:latin typeface="Times New Roman" panose="02020603050405020304" pitchFamily="18" charset="0"/>
+                <a:cs typeface="Times New Roman" panose="02020603050405020304" pitchFamily="18" charset="0"/>
+              </a:rPr>
+              <a:t>Initial Edges</a:t>
+            </a:r>
+          </a:p>
+        </p:txBody>
+      </p:sp>
+      <p:sp>
+        <p:nvSpPr>
+          <p:cNvPr id="16" name="TextBox 15">
+            <a:extLst>
+              <a:ext uri="{FF2B5EF4-FFF2-40B4-BE49-F238E27FC236}">
+                <a16:creationId xmlns:a16="http://schemas.microsoft.com/office/drawing/2014/main" id="{663906BE-2D87-A110-F2C5-B5A0BF5C261C}"/>
+              </a:ext>
+            </a:extLst>
+          </p:cNvPr>
+          <p:cNvSpPr txBox="1"/>
+          <p:nvPr/>
+        </p:nvSpPr>
+        <p:spPr>
+          <a:xfrm>
+            <a:off x="6592465" y="3481892"/>
+            <a:ext cx="412953" cy="307777"/>
+          </a:xfrm>
+          <a:prstGeom prst="rect">
+            <a:avLst/>
+          </a:prstGeom>
+          <a:noFill/>
+        </p:spPr>
+        <p:txBody>
+          <a:bodyPr wrap="square">
+            <a:spAutoFit/>
+          </a:bodyPr>
+          <a:lstStyle/>
+          <a:p>
+            <a:r>
+              <a:rPr lang="en-US" sz="1400" dirty="0">
+                <a:latin typeface="Times New Roman" panose="02020603050405020304" pitchFamily="18" charset="0"/>
+                <a:cs typeface="Times New Roman" panose="02020603050405020304" pitchFamily="18" charset="0"/>
+              </a:rPr>
+              <a:t>Īᵢ⁽ᵏ⁾ </a:t>
+            </a:r>
+          </a:p>
+        </p:txBody>
+      </p:sp>
+      <p:sp>
+        <p:nvSpPr>
+          <p:cNvPr id="19" name="TextBox 18">
+            <a:extLst>
+              <a:ext uri="{FF2B5EF4-FFF2-40B4-BE49-F238E27FC236}">
+                <a16:creationId xmlns:a16="http://schemas.microsoft.com/office/drawing/2014/main" id="{DD5F21EE-1F84-FC45-45C0-9ACC677CA8B5}"/>
+              </a:ext>
+            </a:extLst>
+          </p:cNvPr>
+          <p:cNvSpPr txBox="1"/>
+          <p:nvPr/>
+        </p:nvSpPr>
+        <p:spPr>
+          <a:xfrm>
+            <a:off x="6584431" y="3692543"/>
+            <a:ext cx="685608" cy="307777"/>
+          </a:xfrm>
+          <a:prstGeom prst="rect">
+            <a:avLst/>
+          </a:prstGeom>
+          <a:noFill/>
+        </p:spPr>
+        <p:txBody>
+          <a:bodyPr wrap="square">
+            <a:spAutoFit/>
+          </a:bodyPr>
+          <a:lstStyle/>
+          <a:p>
+            <a:r>
+              <a:rPr lang="en-US" sz="1400" b="1" dirty="0" err="1">
+                <a:latin typeface="Times New Roman" panose="02020603050405020304" pitchFamily="18" charset="0"/>
+                <a:cs typeface="Times New Roman" panose="02020603050405020304" pitchFamily="18" charset="0"/>
+              </a:rPr>
+              <a:t>w</a:t>
+            </a:r>
+            <a:r>
+              <a:rPr lang="en-US" sz="1400" dirty="0" err="1">
+                <a:latin typeface="Times New Roman" panose="02020603050405020304" pitchFamily="18" charset="0"/>
+                <a:cs typeface="Times New Roman" panose="02020603050405020304" pitchFamily="18" charset="0"/>
+              </a:rPr>
+              <a:t>ij</a:t>
+            </a:r>
+            <a:endParaRPr lang="en-US" sz="1400" dirty="0">
+              <a:latin typeface="Times New Roman" panose="02020603050405020304" pitchFamily="18" charset="0"/>
+              <a:cs typeface="Times New Roman" panose="02020603050405020304" pitchFamily="18" charset="0"/>
+            </a:endParaRPr>
+          </a:p>
+        </p:txBody>
+      </p:sp>
+      <p:sp>
+        <p:nvSpPr>
+          <p:cNvPr id="3" name="TextBox 2">
+            <a:extLst>
+              <a:ext uri="{FF2B5EF4-FFF2-40B4-BE49-F238E27FC236}">
+                <a16:creationId xmlns:a16="http://schemas.microsoft.com/office/drawing/2014/main" id="{70C9DEF0-FD71-84FE-9585-9D6E6412DDC9}"/>
+              </a:ext>
+            </a:extLst>
+          </p:cNvPr>
+          <p:cNvSpPr txBox="1"/>
+          <p:nvPr/>
+        </p:nvSpPr>
+        <p:spPr>
+          <a:xfrm>
+            <a:off x="10014673" y="3173604"/>
+            <a:ext cx="663843" cy="261610"/>
+          </a:xfrm>
+          <a:prstGeom prst="rect">
+            <a:avLst/>
+          </a:prstGeom>
+          <a:noFill/>
+        </p:spPr>
+        <p:txBody>
+          <a:bodyPr wrap="square">
+            <a:spAutoFit/>
+          </a:bodyPr>
+          <a:lstStyle/>
+          <a:p>
+            <a:r>
+              <a:rPr lang="en-US" sz="1100" dirty="0">
+                <a:latin typeface="Times New Roman" panose="02020603050405020304" pitchFamily="18" charset="0"/>
+                <a:cs typeface="Times New Roman" panose="02020603050405020304" pitchFamily="18" charset="0"/>
+              </a:rPr>
+              <a:t>Saliency</a:t>
+            </a:r>
+          </a:p>
+        </p:txBody>
+      </p:sp>
+      <p:sp>
+        <p:nvSpPr>
+          <p:cNvPr id="8" name="TextBox 7">
+            <a:extLst>
+              <a:ext uri="{FF2B5EF4-FFF2-40B4-BE49-F238E27FC236}">
+                <a16:creationId xmlns:a16="http://schemas.microsoft.com/office/drawing/2014/main" id="{7FA7AAFE-8ADE-32D8-2918-0AB662920247}"/>
+              </a:ext>
+            </a:extLst>
+          </p:cNvPr>
+          <p:cNvSpPr txBox="1"/>
+          <p:nvPr/>
+        </p:nvSpPr>
+        <p:spPr>
+          <a:xfrm>
+            <a:off x="10024428" y="3685776"/>
+            <a:ext cx="580075" cy="261610"/>
+          </a:xfrm>
+          <a:prstGeom prst="rect">
+            <a:avLst/>
+          </a:prstGeom>
+          <a:noFill/>
+        </p:spPr>
+        <p:txBody>
+          <a:bodyPr wrap="square">
+            <a:spAutoFit/>
+          </a:bodyPr>
+          <a:lstStyle/>
+          <a:p>
+            <a:r>
+              <a:rPr lang="en-US" sz="1100" dirty="0">
+                <a:latin typeface="Times New Roman" panose="02020603050405020304" pitchFamily="18" charset="0"/>
+                <a:cs typeface="Times New Roman" panose="02020603050405020304" pitchFamily="18" charset="0"/>
+              </a:rPr>
+              <a:t>Model</a:t>
             </a:r>
           </a:p>
         </p:txBody>

</xml_diff>